<commit_message>
Add QR code to slide 19 of Demo-3 deck
Rebuilt the Resource Kit slide to include a large QR code on the right
third of the layout. QR targets the branch-pinned URL
https://github.com/CyberRant-lab/Defcon/tree/demo3-resource-kit so audience
members can scan directly to the kit during the closing slide. Kit items
rearranged into two tighter columns on the left 2/3 to make room; repo
root URL remains visible as a bottom strip for redundancy.
</commit_message>
<xml_diff>
--- a/Artifacts/defcon_resource_kit_demo3/01_presentation/defcon_graceful_fail_demo3.pptx
+++ b/Artifacts/defcon_resource_kit_demo3/01_presentation/defcon_graceful_fail_demo3.pptx
@@ -12769,23 +12769,23 @@
         </p:nvSpPr>
         <p:spPr>
           <a:xfrm>
-            <a:off x="640080" y="1645920"/>
-            <a:ext cx="5394960" cy="411480"/>
-          </a:xfrm>
-          <a:prstGeom prst="rect">
-            <a:avLst/>
-          </a:prstGeom>
-          <a:noFill/>
-        </p:spPr>
-        <p:txBody>
-          <a:bodyPr wrap="square" lIns="0" rIns="0" tIns="0" bIns="0" anchor="t">
-            <a:spAutoFit/>
-          </a:bodyPr>
-          <a:lstStyle/>
-          <a:p>
-            <a:pPr algn="l"/>
-            <a:r>
-              <a:rPr sz="1400" b="1" i="0">
+            <a:off x="457200" y="1600200"/>
+            <a:ext cx="3703320" cy="347472"/>
+          </a:xfrm>
+          <a:prstGeom prst="rect">
+            <a:avLst/>
+          </a:prstGeom>
+          <a:noFill/>
+        </p:spPr>
+        <p:txBody>
+          <a:bodyPr wrap="square" lIns="0" rIns="0" tIns="0" bIns="0" anchor="t">
+            <a:spAutoFit/>
+          </a:bodyPr>
+          <a:lstStyle/>
+          <a:p>
+            <a:pPr algn="l"/>
+            <a:r>
+              <a:rPr sz="1300" b="1" i="0">
                 <a:solidFill>
                   <a:srgbClr val="3BD67A"/>
                 </a:solidFill>
@@ -12804,23 +12804,23 @@
         </p:nvSpPr>
         <p:spPr>
           <a:xfrm>
-            <a:off x="640080" y="2029968"/>
-            <a:ext cx="5394960" cy="457200"/>
-          </a:xfrm>
-          <a:prstGeom prst="rect">
-            <a:avLst/>
-          </a:prstGeom>
-          <a:noFill/>
-        </p:spPr>
-        <p:txBody>
-          <a:bodyPr wrap="square" lIns="0" rIns="0" tIns="0" bIns="0" anchor="t">
-            <a:spAutoFit/>
-          </a:bodyPr>
-          <a:lstStyle/>
-          <a:p>
-            <a:pPr algn="l"/>
-            <a:r>
-              <a:rPr sz="1100" b="0" i="0">
+            <a:off x="457200" y="1965960"/>
+            <a:ext cx="3703320" cy="457200"/>
+          </a:xfrm>
+          <a:prstGeom prst="rect">
+            <a:avLst/>
+          </a:prstGeom>
+          <a:noFill/>
+        </p:spPr>
+        <p:txBody>
+          <a:bodyPr wrap="square" lIns="0" rIns="0" tIns="0" bIns="0" anchor="t">
+            <a:spAutoFit/>
+          </a:bodyPr>
+          <a:lstStyle/>
+          <a:p>
+            <a:pPr algn="l"/>
+            <a:r>
+              <a:rPr sz="1000" b="0" i="0">
                 <a:solidFill>
                   <a:srgbClr val="98A49C"/>
                 </a:solidFill>
@@ -12839,23 +12839,23 @@
         </p:nvSpPr>
         <p:spPr>
           <a:xfrm>
-            <a:off x="640080" y="2560320"/>
-            <a:ext cx="5394960" cy="411480"/>
-          </a:xfrm>
-          <a:prstGeom prst="rect">
-            <a:avLst/>
-          </a:prstGeom>
-          <a:noFill/>
-        </p:spPr>
-        <p:txBody>
-          <a:bodyPr wrap="square" lIns="0" rIns="0" tIns="0" bIns="0" anchor="t">
-            <a:spAutoFit/>
-          </a:bodyPr>
-          <a:lstStyle/>
-          <a:p>
-            <a:pPr algn="l"/>
-            <a:r>
-              <a:rPr sz="1400" b="1" i="0">
+            <a:off x="457200" y="2532888"/>
+            <a:ext cx="3703320" cy="347472"/>
+          </a:xfrm>
+          <a:prstGeom prst="rect">
+            <a:avLst/>
+          </a:prstGeom>
+          <a:noFill/>
+        </p:spPr>
+        <p:txBody>
+          <a:bodyPr wrap="square" lIns="0" rIns="0" tIns="0" bIns="0" anchor="t">
+            <a:spAutoFit/>
+          </a:bodyPr>
+          <a:lstStyle/>
+          <a:p>
+            <a:pPr algn="l"/>
+            <a:r>
+              <a:rPr sz="1300" b="1" i="0">
                 <a:solidFill>
                   <a:srgbClr val="3BD67A"/>
                 </a:solidFill>
@@ -12874,23 +12874,23 @@
         </p:nvSpPr>
         <p:spPr>
           <a:xfrm>
-            <a:off x="640080" y="2944368"/>
-            <a:ext cx="5394960" cy="457200"/>
-          </a:xfrm>
-          <a:prstGeom prst="rect">
-            <a:avLst/>
-          </a:prstGeom>
-          <a:noFill/>
-        </p:spPr>
-        <p:txBody>
-          <a:bodyPr wrap="square" lIns="0" rIns="0" tIns="0" bIns="0" anchor="t">
-            <a:spAutoFit/>
-          </a:bodyPr>
-          <a:lstStyle/>
-          <a:p>
-            <a:pPr algn="l"/>
-            <a:r>
-              <a:rPr sz="1100" b="0" i="0">
+            <a:off x="457200" y="2898648"/>
+            <a:ext cx="3703320" cy="457200"/>
+          </a:xfrm>
+          <a:prstGeom prst="rect">
+            <a:avLst/>
+          </a:prstGeom>
+          <a:noFill/>
+        </p:spPr>
+        <p:txBody>
+          <a:bodyPr wrap="square" lIns="0" rIns="0" tIns="0" bIns="0" anchor="t">
+            <a:spAutoFit/>
+          </a:bodyPr>
+          <a:lstStyle/>
+          <a:p>
+            <a:pPr algn="l"/>
+            <a:r>
+              <a:rPr sz="1000" b="0" i="0">
                 <a:solidFill>
                   <a:srgbClr val="98A49C"/>
                 </a:solidFill>
@@ -12909,23 +12909,23 @@
         </p:nvSpPr>
         <p:spPr>
           <a:xfrm>
-            <a:off x="640080" y="3474720"/>
-            <a:ext cx="5394960" cy="411480"/>
-          </a:xfrm>
-          <a:prstGeom prst="rect">
-            <a:avLst/>
-          </a:prstGeom>
-          <a:noFill/>
-        </p:spPr>
-        <p:txBody>
-          <a:bodyPr wrap="square" lIns="0" rIns="0" tIns="0" bIns="0" anchor="t">
-            <a:spAutoFit/>
-          </a:bodyPr>
-          <a:lstStyle/>
-          <a:p>
-            <a:pPr algn="l"/>
-            <a:r>
-              <a:rPr sz="1400" b="1" i="0">
+            <a:off x="457200" y="3465576"/>
+            <a:ext cx="3703320" cy="347472"/>
+          </a:xfrm>
+          <a:prstGeom prst="rect">
+            <a:avLst/>
+          </a:prstGeom>
+          <a:noFill/>
+        </p:spPr>
+        <p:txBody>
+          <a:bodyPr wrap="square" lIns="0" rIns="0" tIns="0" bIns="0" anchor="t">
+            <a:spAutoFit/>
+          </a:bodyPr>
+          <a:lstStyle/>
+          <a:p>
+            <a:pPr algn="l"/>
+            <a:r>
+              <a:rPr sz="1300" b="1" i="0">
                 <a:solidFill>
                   <a:srgbClr val="3BD67A"/>
                 </a:solidFill>
@@ -12944,23 +12944,23 @@
         </p:nvSpPr>
         <p:spPr>
           <a:xfrm>
-            <a:off x="640080" y="3858768"/>
-            <a:ext cx="5394960" cy="457200"/>
-          </a:xfrm>
-          <a:prstGeom prst="rect">
-            <a:avLst/>
-          </a:prstGeom>
-          <a:noFill/>
-        </p:spPr>
-        <p:txBody>
-          <a:bodyPr wrap="square" lIns="0" rIns="0" tIns="0" bIns="0" anchor="t">
-            <a:spAutoFit/>
-          </a:bodyPr>
-          <a:lstStyle/>
-          <a:p>
-            <a:pPr algn="l"/>
-            <a:r>
-              <a:rPr sz="1100" b="0" i="0">
+            <a:off x="457200" y="3831336"/>
+            <a:ext cx="3703320" cy="457200"/>
+          </a:xfrm>
+          <a:prstGeom prst="rect">
+            <a:avLst/>
+          </a:prstGeom>
+          <a:noFill/>
+        </p:spPr>
+        <p:txBody>
+          <a:bodyPr wrap="square" lIns="0" rIns="0" tIns="0" bIns="0" anchor="t">
+            <a:spAutoFit/>
+          </a:bodyPr>
+          <a:lstStyle/>
+          <a:p>
+            <a:pPr algn="l"/>
+            <a:r>
+              <a:rPr sz="1000" b="0" i="0">
                 <a:solidFill>
                   <a:srgbClr val="98A49C"/>
                 </a:solidFill>
@@ -12979,23 +12979,23 @@
         </p:nvSpPr>
         <p:spPr>
           <a:xfrm>
-            <a:off x="640080" y="4389120"/>
-            <a:ext cx="5394960" cy="411480"/>
-          </a:xfrm>
-          <a:prstGeom prst="rect">
-            <a:avLst/>
-          </a:prstGeom>
-          <a:noFill/>
-        </p:spPr>
-        <p:txBody>
-          <a:bodyPr wrap="square" lIns="0" rIns="0" tIns="0" bIns="0" anchor="t">
-            <a:spAutoFit/>
-          </a:bodyPr>
-          <a:lstStyle/>
-          <a:p>
-            <a:pPr algn="l"/>
-            <a:r>
-              <a:rPr sz="1400" b="1" i="0">
+            <a:off x="457200" y="4398264"/>
+            <a:ext cx="3703320" cy="347472"/>
+          </a:xfrm>
+          <a:prstGeom prst="rect">
+            <a:avLst/>
+          </a:prstGeom>
+          <a:noFill/>
+        </p:spPr>
+        <p:txBody>
+          <a:bodyPr wrap="square" lIns="0" rIns="0" tIns="0" bIns="0" anchor="t">
+            <a:spAutoFit/>
+          </a:bodyPr>
+          <a:lstStyle/>
+          <a:p>
+            <a:pPr algn="l"/>
+            <a:r>
+              <a:rPr sz="1300" b="1" i="0">
                 <a:solidFill>
                   <a:srgbClr val="3BD67A"/>
                 </a:solidFill>
@@ -13014,29 +13014,29 @@
         </p:nvSpPr>
         <p:spPr>
           <a:xfrm>
-            <a:off x="640080" y="4773168"/>
-            <a:ext cx="5394960" cy="457200"/>
-          </a:xfrm>
-          <a:prstGeom prst="rect">
-            <a:avLst/>
-          </a:prstGeom>
-          <a:noFill/>
-        </p:spPr>
-        <p:txBody>
-          <a:bodyPr wrap="square" lIns="0" rIns="0" tIns="0" bIns="0" anchor="t">
-            <a:spAutoFit/>
-          </a:bodyPr>
-          <a:lstStyle/>
-          <a:p>
-            <a:pPr algn="l"/>
-            <a:r>
-              <a:rPr sz="1100" b="0" i="0">
+            <a:off x="457200" y="4764024"/>
+            <a:ext cx="3703320" cy="457200"/>
+          </a:xfrm>
+          <a:prstGeom prst="rect">
+            <a:avLst/>
+          </a:prstGeom>
+          <a:noFill/>
+        </p:spPr>
+        <p:txBody>
+          <a:bodyPr wrap="square" lIns="0" rIns="0" tIns="0" bIns="0" anchor="t">
+            <a:spAutoFit/>
+          </a:bodyPr>
+          <a:lstStyle/>
+          <a:p>
+            <a:pPr algn="l"/>
+            <a:r>
+              <a:rPr sz="1000" b="0" i="0">
                 <a:solidFill>
                   <a:srgbClr val="98A49C"/>
                 </a:solidFill>
                 <a:latin typeface="Helvetica"/>
               </a:rPr>
-              <a:t>6 attack cards across 4 tiers (2hr lab)</a:t>
+              <a:t>6 attack cards across 4 tiers (2-hour lab)</a:t>
             </a:r>
           </a:p>
         </p:txBody>
@@ -13049,23 +13049,23 @@
         </p:nvSpPr>
         <p:spPr>
           <a:xfrm>
-            <a:off x="640080" y="5303520"/>
-            <a:ext cx="5394960" cy="411480"/>
-          </a:xfrm>
-          <a:prstGeom prst="rect">
-            <a:avLst/>
-          </a:prstGeom>
-          <a:noFill/>
-        </p:spPr>
-        <p:txBody>
-          <a:bodyPr wrap="square" lIns="0" rIns="0" tIns="0" bIns="0" anchor="t">
-            <a:spAutoFit/>
-          </a:bodyPr>
-          <a:lstStyle/>
-          <a:p>
-            <a:pPr algn="l"/>
-            <a:r>
-              <a:rPr sz="1400" b="1" i="0">
+            <a:off x="457200" y="5330952"/>
+            <a:ext cx="3703320" cy="347472"/>
+          </a:xfrm>
+          <a:prstGeom prst="rect">
+            <a:avLst/>
+          </a:prstGeom>
+          <a:noFill/>
+        </p:spPr>
+        <p:txBody>
+          <a:bodyPr wrap="square" lIns="0" rIns="0" tIns="0" bIns="0" anchor="t">
+            <a:spAutoFit/>
+          </a:bodyPr>
+          <a:lstStyle/>
+          <a:p>
+            <a:pPr algn="l"/>
+            <a:r>
+              <a:rPr sz="1300" b="1" i="0">
                 <a:solidFill>
                   <a:srgbClr val="3BD67A"/>
                 </a:solidFill>
@@ -13084,23 +13084,23 @@
         </p:nvSpPr>
         <p:spPr>
           <a:xfrm>
-            <a:off x="640080" y="5687568"/>
-            <a:ext cx="5394960" cy="457200"/>
-          </a:xfrm>
-          <a:prstGeom prst="rect">
-            <a:avLst/>
-          </a:prstGeom>
-          <a:noFill/>
-        </p:spPr>
-        <p:txBody>
-          <a:bodyPr wrap="square" lIns="0" rIns="0" tIns="0" bIns="0" anchor="t">
-            <a:spAutoFit/>
-          </a:bodyPr>
-          <a:lstStyle/>
-          <a:p>
-            <a:pPr algn="l"/>
-            <a:r>
-              <a:rPr sz="1100" b="0" i="0">
+            <a:off x="457200" y="5696712"/>
+            <a:ext cx="3703320" cy="457200"/>
+          </a:xfrm>
+          <a:prstGeom prst="rect">
+            <a:avLst/>
+          </a:prstGeom>
+          <a:noFill/>
+        </p:spPr>
+        <p:txBody>
+          <a:bodyPr wrap="square" lIns="0" rIns="0" tIns="0" bIns="0" anchor="t">
+            <a:spAutoFit/>
+          </a:bodyPr>
+          <a:lstStyle/>
+          <a:p>
+            <a:pPr algn="l"/>
+            <a:r>
+              <a:rPr sz="1000" b="0" i="0">
                 <a:solidFill>
                   <a:srgbClr val="98A49C"/>
                 </a:solidFill>
@@ -13119,23 +13119,23 @@
         </p:nvSpPr>
         <p:spPr>
           <a:xfrm>
-            <a:off x="6400800" y="1645920"/>
-            <a:ext cx="5394960" cy="411480"/>
-          </a:xfrm>
-          <a:prstGeom prst="rect">
-            <a:avLst/>
-          </a:prstGeom>
-          <a:noFill/>
-        </p:spPr>
-        <p:txBody>
-          <a:bodyPr wrap="square" lIns="0" rIns="0" tIns="0" bIns="0" anchor="t">
-            <a:spAutoFit/>
-          </a:bodyPr>
-          <a:lstStyle/>
-          <a:p>
-            <a:pPr algn="l"/>
-            <a:r>
-              <a:rPr sz="1400" b="1" i="0">
+            <a:off x="4251960" y="1600200"/>
+            <a:ext cx="3703320" cy="347472"/>
+          </a:xfrm>
+          <a:prstGeom prst="rect">
+            <a:avLst/>
+          </a:prstGeom>
+          <a:noFill/>
+        </p:spPr>
+        <p:txBody>
+          <a:bodyPr wrap="square" lIns="0" rIns="0" tIns="0" bIns="0" anchor="t">
+            <a:spAutoFit/>
+          </a:bodyPr>
+          <a:lstStyle/>
+          <a:p>
+            <a:pPr algn="l"/>
+            <a:r>
+              <a:rPr sz="1300" b="1" i="0">
                 <a:solidFill>
                   <a:srgbClr val="3BD67A"/>
                 </a:solidFill>
@@ -13154,23 +13154,23 @@
         </p:nvSpPr>
         <p:spPr>
           <a:xfrm>
-            <a:off x="6400800" y="2029968"/>
-            <a:ext cx="5394960" cy="457200"/>
-          </a:xfrm>
-          <a:prstGeom prst="rect">
-            <a:avLst/>
-          </a:prstGeom>
-          <a:noFill/>
-        </p:spPr>
-        <p:txBody>
-          <a:bodyPr wrap="square" lIns="0" rIns="0" tIns="0" bIns="0" anchor="t">
-            <a:spAutoFit/>
-          </a:bodyPr>
-          <a:lstStyle/>
-          <a:p>
-            <a:pPr algn="l"/>
-            <a:r>
-              <a:rPr sz="1100" b="0" i="0">
+            <a:off x="4251960" y="1965960"/>
+            <a:ext cx="3703320" cy="457200"/>
+          </a:xfrm>
+          <a:prstGeom prst="rect">
+            <a:avLst/>
+          </a:prstGeom>
+          <a:noFill/>
+        </p:spPr>
+        <p:txBody>
+          <a:bodyPr wrap="square" lIns="0" rIns="0" tIns="0" bIns="0" anchor="t">
+            <a:spAutoFit/>
+          </a:bodyPr>
+          <a:lstStyle/>
+          <a:p>
+            <a:pPr algn="l"/>
+            <a:r>
+              <a:rPr sz="1000" b="0" i="0">
                 <a:solidFill>
                   <a:srgbClr val="98A49C"/>
                 </a:solidFill>
@@ -13189,23 +13189,23 @@
         </p:nvSpPr>
         <p:spPr>
           <a:xfrm>
-            <a:off x="6400800" y="2560320"/>
-            <a:ext cx="5394960" cy="411480"/>
-          </a:xfrm>
-          <a:prstGeom prst="rect">
-            <a:avLst/>
-          </a:prstGeom>
-          <a:noFill/>
-        </p:spPr>
-        <p:txBody>
-          <a:bodyPr wrap="square" lIns="0" rIns="0" tIns="0" bIns="0" anchor="t">
-            <a:spAutoFit/>
-          </a:bodyPr>
-          <a:lstStyle/>
-          <a:p>
-            <a:pPr algn="l"/>
-            <a:r>
-              <a:rPr sz="1400" b="1" i="0">
+            <a:off x="4251960" y="2532888"/>
+            <a:ext cx="3703320" cy="347472"/>
+          </a:xfrm>
+          <a:prstGeom prst="rect">
+            <a:avLst/>
+          </a:prstGeom>
+          <a:noFill/>
+        </p:spPr>
+        <p:txBody>
+          <a:bodyPr wrap="square" lIns="0" rIns="0" tIns="0" bIns="0" anchor="t">
+            <a:spAutoFit/>
+          </a:bodyPr>
+          <a:lstStyle/>
+          <a:p>
+            <a:pPr algn="l"/>
+            <a:r>
+              <a:rPr sz="1300" b="1" i="0">
                 <a:solidFill>
                   <a:srgbClr val="3BD67A"/>
                 </a:solidFill>
@@ -13224,23 +13224,23 @@
         </p:nvSpPr>
         <p:spPr>
           <a:xfrm>
-            <a:off x="6400800" y="2944368"/>
-            <a:ext cx="5394960" cy="457200"/>
-          </a:xfrm>
-          <a:prstGeom prst="rect">
-            <a:avLst/>
-          </a:prstGeom>
-          <a:noFill/>
-        </p:spPr>
-        <p:txBody>
-          <a:bodyPr wrap="square" lIns="0" rIns="0" tIns="0" bIns="0" anchor="t">
-            <a:spAutoFit/>
-          </a:bodyPr>
-          <a:lstStyle/>
-          <a:p>
-            <a:pPr algn="l"/>
-            <a:r>
-              <a:rPr sz="1100" b="0" i="0">
+            <a:off x="4251960" y="2898648"/>
+            <a:ext cx="3703320" cy="457200"/>
+          </a:xfrm>
+          <a:prstGeom prst="rect">
+            <a:avLst/>
+          </a:prstGeom>
+          <a:noFill/>
+        </p:spPr>
+        <p:txBody>
+          <a:bodyPr wrap="square" lIns="0" rIns="0" tIns="0" bIns="0" anchor="t">
+            <a:spAutoFit/>
+          </a:bodyPr>
+          <a:lstStyle/>
+          <a:p>
+            <a:pPr algn="l"/>
+            <a:r>
+              <a:rPr sz="1000" b="0" i="0">
                 <a:solidFill>
                   <a:srgbClr val="98A49C"/>
                 </a:solidFill>
@@ -13259,23 +13259,23 @@
         </p:nvSpPr>
         <p:spPr>
           <a:xfrm>
-            <a:off x="6400800" y="3474720"/>
-            <a:ext cx="5394960" cy="411480"/>
-          </a:xfrm>
-          <a:prstGeom prst="rect">
-            <a:avLst/>
-          </a:prstGeom>
-          <a:noFill/>
-        </p:spPr>
-        <p:txBody>
-          <a:bodyPr wrap="square" lIns="0" rIns="0" tIns="0" bIns="0" anchor="t">
-            <a:spAutoFit/>
-          </a:bodyPr>
-          <a:lstStyle/>
-          <a:p>
-            <a:pPr algn="l"/>
-            <a:r>
-              <a:rPr sz="1400" b="1" i="0">
+            <a:off x="4251960" y="3465576"/>
+            <a:ext cx="3703320" cy="347472"/>
+          </a:xfrm>
+          <a:prstGeom prst="rect">
+            <a:avLst/>
+          </a:prstGeom>
+          <a:noFill/>
+        </p:spPr>
+        <p:txBody>
+          <a:bodyPr wrap="square" lIns="0" rIns="0" tIns="0" bIns="0" anchor="t">
+            <a:spAutoFit/>
+          </a:bodyPr>
+          <a:lstStyle/>
+          <a:p>
+            <a:pPr algn="l"/>
+            <a:r>
+              <a:rPr sz="1300" b="1" i="0">
                 <a:solidFill>
                   <a:srgbClr val="3BD67A"/>
                 </a:solidFill>
@@ -13294,23 +13294,23 @@
         </p:nvSpPr>
         <p:spPr>
           <a:xfrm>
-            <a:off x="6400800" y="3858768"/>
-            <a:ext cx="5394960" cy="457200"/>
-          </a:xfrm>
-          <a:prstGeom prst="rect">
-            <a:avLst/>
-          </a:prstGeom>
-          <a:noFill/>
-        </p:spPr>
-        <p:txBody>
-          <a:bodyPr wrap="square" lIns="0" rIns="0" tIns="0" bIns="0" anchor="t">
-            <a:spAutoFit/>
-          </a:bodyPr>
-          <a:lstStyle/>
-          <a:p>
-            <a:pPr algn="l"/>
-            <a:r>
-              <a:rPr sz="1100" b="0" i="0">
+            <a:off x="4251960" y="3831336"/>
+            <a:ext cx="3703320" cy="457200"/>
+          </a:xfrm>
+          <a:prstGeom prst="rect">
+            <a:avLst/>
+          </a:prstGeom>
+          <a:noFill/>
+        </p:spPr>
+        <p:txBody>
+          <a:bodyPr wrap="square" lIns="0" rIns="0" tIns="0" bIns="0" anchor="t">
+            <a:spAutoFit/>
+          </a:bodyPr>
+          <a:lstStyle/>
+          <a:p>
+            <a:pPr algn="l"/>
+            <a:r>
+              <a:rPr sz="1000" b="0" i="0">
                 <a:solidFill>
                   <a:srgbClr val="98A49C"/>
                 </a:solidFill>
@@ -13329,23 +13329,23 @@
         </p:nvSpPr>
         <p:spPr>
           <a:xfrm>
-            <a:off x="6400800" y="4389120"/>
-            <a:ext cx="5394960" cy="411480"/>
-          </a:xfrm>
-          <a:prstGeom prst="rect">
-            <a:avLst/>
-          </a:prstGeom>
-          <a:noFill/>
-        </p:spPr>
-        <p:txBody>
-          <a:bodyPr wrap="square" lIns="0" rIns="0" tIns="0" bIns="0" anchor="t">
-            <a:spAutoFit/>
-          </a:bodyPr>
-          <a:lstStyle/>
-          <a:p>
-            <a:pPr algn="l"/>
-            <a:r>
-              <a:rPr sz="1400" b="1" i="0">
+            <a:off x="4251960" y="4398264"/>
+            <a:ext cx="3703320" cy="347472"/>
+          </a:xfrm>
+          <a:prstGeom prst="rect">
+            <a:avLst/>
+          </a:prstGeom>
+          <a:noFill/>
+        </p:spPr>
+        <p:txBody>
+          <a:bodyPr wrap="square" lIns="0" rIns="0" tIns="0" bIns="0" anchor="t">
+            <a:spAutoFit/>
+          </a:bodyPr>
+          <a:lstStyle/>
+          <a:p>
+            <a:pPr algn="l"/>
+            <a:r>
+              <a:rPr sz="1300" b="1" i="0">
                 <a:solidFill>
                   <a:srgbClr val="3BD67A"/>
                 </a:solidFill>
@@ -13364,23 +13364,23 @@
         </p:nvSpPr>
         <p:spPr>
           <a:xfrm>
-            <a:off x="6400800" y="4773168"/>
-            <a:ext cx="5394960" cy="457200"/>
-          </a:xfrm>
-          <a:prstGeom prst="rect">
-            <a:avLst/>
-          </a:prstGeom>
-          <a:noFill/>
-        </p:spPr>
-        <p:txBody>
-          <a:bodyPr wrap="square" lIns="0" rIns="0" tIns="0" bIns="0" anchor="t">
-            <a:spAutoFit/>
-          </a:bodyPr>
-          <a:lstStyle/>
-          <a:p>
-            <a:pPr algn="l"/>
-            <a:r>
-              <a:rPr sz="1100" b="0" i="0">
+            <a:off x="4251960" y="4764024"/>
+            <a:ext cx="3703320" cy="457200"/>
+          </a:xfrm>
+          <a:prstGeom prst="rect">
+            <a:avLst/>
+          </a:prstGeom>
+          <a:noFill/>
+        </p:spPr>
+        <p:txBody>
+          <a:bodyPr wrap="square" lIns="0" rIns="0" tIns="0" bIns="0" anchor="t">
+            <a:spAutoFit/>
+          </a:bodyPr>
+          <a:lstStyle/>
+          <a:p>
+            <a:pPr algn="l"/>
+            <a:r>
+              <a:rPr sz="1000" b="0" i="0">
                 <a:solidFill>
                   <a:srgbClr val="98A49C"/>
                 </a:solidFill>
@@ -13399,23 +13399,23 @@
         </p:nvSpPr>
         <p:spPr>
           <a:xfrm>
-            <a:off x="6400800" y="5303520"/>
-            <a:ext cx="5394960" cy="411480"/>
-          </a:xfrm>
-          <a:prstGeom prst="rect">
-            <a:avLst/>
-          </a:prstGeom>
-          <a:noFill/>
-        </p:spPr>
-        <p:txBody>
-          <a:bodyPr wrap="square" lIns="0" rIns="0" tIns="0" bIns="0" anchor="t">
-            <a:spAutoFit/>
-          </a:bodyPr>
-          <a:lstStyle/>
-          <a:p>
-            <a:pPr algn="l"/>
-            <a:r>
-              <a:rPr sz="1400" b="1" i="0">
+            <a:off x="4251960" y="5330952"/>
+            <a:ext cx="3703320" cy="347472"/>
+          </a:xfrm>
+          <a:prstGeom prst="rect">
+            <a:avLst/>
+          </a:prstGeom>
+          <a:noFill/>
+        </p:spPr>
+        <p:txBody>
+          <a:bodyPr wrap="square" lIns="0" rIns="0" tIns="0" bIns="0" anchor="t">
+            <a:spAutoFit/>
+          </a:bodyPr>
+          <a:lstStyle/>
+          <a:p>
+            <a:pPr algn="l"/>
+            <a:r>
+              <a:rPr sz="1300" b="1" i="0">
                 <a:solidFill>
                   <a:srgbClr val="3BD67A"/>
                 </a:solidFill>
@@ -13434,23 +13434,23 @@
         </p:nvSpPr>
         <p:spPr>
           <a:xfrm>
-            <a:off x="6400800" y="5687568"/>
-            <a:ext cx="5394960" cy="457200"/>
-          </a:xfrm>
-          <a:prstGeom prst="rect">
-            <a:avLst/>
-          </a:prstGeom>
-          <a:noFill/>
-        </p:spPr>
-        <p:txBody>
-          <a:bodyPr wrap="square" lIns="0" rIns="0" tIns="0" bIns="0" anchor="t">
-            <a:spAutoFit/>
-          </a:bodyPr>
-          <a:lstStyle/>
-          <a:p>
-            <a:pPr algn="l"/>
-            <a:r>
-              <a:rPr sz="1100" b="0" i="0">
+            <a:off x="4251960" y="5696712"/>
+            <a:ext cx="3703320" cy="457200"/>
+          </a:xfrm>
+          <a:prstGeom prst="rect">
+            <a:avLst/>
+          </a:prstGeom>
+          <a:noFill/>
+        </p:spPr>
+        <p:txBody>
+          <a:bodyPr wrap="square" lIns="0" rIns="0" tIns="0" bIns="0" anchor="t">
+            <a:spAutoFit/>
+          </a:bodyPr>
+          <a:lstStyle/>
+          <a:p>
+            <a:pPr algn="l"/>
+            <a:r>
+              <a:rPr sz="1000" b="0" i="0">
                 <a:solidFill>
                   <a:srgbClr val="98A49C"/>
                 </a:solidFill>
@@ -13463,35 +13463,233 @@
       </p:sp>
       <p:sp>
         <p:nvSpPr>
-          <p:cNvPr id="27" name="TextBox 26"/>
-          <p:cNvSpPr txBox="1"/>
-          <p:nvPr/>
-        </p:nvSpPr>
-        <p:spPr>
-          <a:xfrm>
-            <a:off x="640080" y="6400800"/>
-            <a:ext cx="10972800" cy="274320"/>
-          </a:xfrm>
-          <a:prstGeom prst="rect">
-            <a:avLst/>
-          </a:prstGeom>
-          <a:noFill/>
-        </p:spPr>
-        <p:txBody>
-          <a:bodyPr wrap="square" lIns="0" rIns="0" tIns="0" bIns="0" anchor="t">
-            <a:spAutoFit/>
-          </a:bodyPr>
+          <p:cNvPr id="27" name="Rectangle 26"/>
+          <p:cNvSpPr/>
+          <p:nvPr/>
+        </p:nvSpPr>
+        <p:spPr>
+          <a:xfrm>
+            <a:off x="8412480" y="1600200"/>
+            <a:ext cx="3291840" cy="4434840"/>
+          </a:xfrm>
+          <a:prstGeom prst="rect">
+            <a:avLst/>
+          </a:prstGeom>
+          <a:solidFill>
+            <a:srgbClr val="FFFFFF"/>
+          </a:solidFill>
+          <a:ln w="25400">
+            <a:solidFill>
+              <a:srgbClr val="3BD67A"/>
+            </a:solidFill>
+          </a:ln>
+          <a:effectLst/>
+        </p:spPr>
+        <p:style>
+          <a:lnRef idx="1">
+            <a:schemeClr val="accent1"/>
+          </a:lnRef>
+          <a:fillRef idx="3">
+            <a:schemeClr val="accent1"/>
+          </a:fillRef>
+          <a:effectRef idx="2">
+            <a:schemeClr val="accent1"/>
+          </a:effectRef>
+          <a:fontRef idx="minor">
+            <a:schemeClr val="lt1"/>
+          </a:fontRef>
+        </p:style>
+        <p:txBody>
+          <a:bodyPr rtlCol="0" anchor="ctr"/>
           <a:lstStyle/>
           <a:p>
             <a:pPr algn="ctr"/>
-            <a:r>
-              <a:rPr sz="1200" b="1" i="0">
+          </a:p>
+        </p:txBody>
+      </p:sp>
+      <p:pic>
+        <p:nvPicPr>
+          <p:cNvPr id="28" name="Picture 27" descr="image.png"/>
+          <p:cNvPicPr>
+            <a:picLocks noChangeAspect="1"/>
+          </p:cNvPicPr>
+          <p:nvPr/>
+        </p:nvPicPr>
+        <p:blipFill>
+          <a:blip r:embed="rId3"/>
+          <a:stretch>
+            <a:fillRect/>
+          </a:stretch>
+        </p:blipFill>
+        <p:spPr>
+          <a:xfrm>
+            <a:off x="8641080" y="1828800"/>
+            <a:ext cx="2834640" cy="2834640"/>
+          </a:xfrm>
+          <a:prstGeom prst="rect">
+            <a:avLst/>
+          </a:prstGeom>
+        </p:spPr>
+      </p:pic>
+      <p:sp>
+        <p:nvSpPr>
+          <p:cNvPr id="29" name="TextBox 28"/>
+          <p:cNvSpPr txBox="1"/>
+          <p:nvPr/>
+        </p:nvSpPr>
+        <p:spPr>
+          <a:xfrm>
+            <a:off x="8412480" y="4800600"/>
+            <a:ext cx="3291840" cy="365760"/>
+          </a:xfrm>
+          <a:prstGeom prst="rect">
+            <a:avLst/>
+          </a:prstGeom>
+          <a:noFill/>
+        </p:spPr>
+        <p:txBody>
+          <a:bodyPr wrap="square" lIns="0" rIns="0" tIns="0" bIns="0" anchor="t">
+            <a:spAutoFit/>
+          </a:bodyPr>
+          <a:lstStyle/>
+          <a:p>
+            <a:pPr algn="ctr"/>
+            <a:r>
+              <a:rPr sz="1300" b="1" i="0">
+                <a:solidFill>
+                  <a:srgbClr val="0A1510"/>
+                </a:solidFill>
+                <a:latin typeface="Helvetica"/>
+              </a:rPr>
+              <a:t>Scan to open the kit</a:t>
+            </a:r>
+          </a:p>
+        </p:txBody>
+      </p:sp>
+      <p:sp>
+        <p:nvSpPr>
+          <p:cNvPr id="30" name="TextBox 29"/>
+          <p:cNvSpPr txBox="1"/>
+          <p:nvPr/>
+        </p:nvSpPr>
+        <p:spPr>
+          <a:xfrm>
+            <a:off x="8412480" y="5166360"/>
+            <a:ext cx="3291840" cy="457200"/>
+          </a:xfrm>
+          <a:prstGeom prst="rect">
+            <a:avLst/>
+          </a:prstGeom>
+          <a:noFill/>
+        </p:spPr>
+        <p:txBody>
+          <a:bodyPr wrap="square" lIns="0" rIns="0" tIns="0" bIns="0" anchor="t">
+            <a:spAutoFit/>
+          </a:bodyPr>
+          <a:lstStyle/>
+          <a:p>
+            <a:pPr algn="ctr"/>
+            <a:r>
+              <a:rPr sz="900" b="0" i="0">
+                <a:solidFill>
+                  <a:srgbClr val="144D28"/>
+                </a:solidFill>
+                <a:latin typeface="Menlo"/>
+              </a:rPr>
+              <a:t>github.com/CyberRant-lab/Defcon</a:t>
+            </a:r>
+          </a:p>
+          <a:p>
+            <a:pPr algn="ctr"/>
+            <a:r>
+              <a:rPr sz="900" b="0" i="0">
+                <a:solidFill>
+                  <a:srgbClr val="144D28"/>
+                </a:solidFill>
+                <a:latin typeface="Menlo"/>
+              </a:rPr>
+              <a:t>/tree/demo3-resource-kit</a:t>
+            </a:r>
+          </a:p>
+        </p:txBody>
+      </p:sp>
+      <p:sp>
+        <p:nvSpPr>
+          <p:cNvPr id="31" name="Rectangle 30"/>
+          <p:cNvSpPr/>
+          <p:nvPr/>
+        </p:nvSpPr>
+        <p:spPr>
+          <a:xfrm>
+            <a:off x="457200" y="6355080"/>
+            <a:ext cx="7680960" cy="201168"/>
+          </a:xfrm>
+          <a:prstGeom prst="rect">
+            <a:avLst/>
+          </a:prstGeom>
+          <a:solidFill>
+            <a:srgbClr val="0F1F17"/>
+          </a:solidFill>
+          <a:ln>
+            <a:solidFill>
+              <a:srgbClr val="0F1F17"/>
+            </a:solidFill>
+          </a:ln>
+          <a:effectLst/>
+        </p:spPr>
+        <p:style>
+          <a:lnRef idx="1">
+            <a:schemeClr val="accent1"/>
+          </a:lnRef>
+          <a:fillRef idx="3">
+            <a:schemeClr val="accent1"/>
+          </a:fillRef>
+          <a:effectRef idx="2">
+            <a:schemeClr val="accent1"/>
+          </a:effectRef>
+          <a:fontRef idx="minor">
+            <a:schemeClr val="lt1"/>
+          </a:fontRef>
+        </p:style>
+        <p:txBody>
+          <a:bodyPr rtlCol="0" anchor="ctr"/>
+          <a:lstStyle/>
+          <a:p>
+            <a:pPr algn="ctr"/>
+          </a:p>
+        </p:txBody>
+      </p:sp>
+      <p:sp>
+        <p:nvSpPr>
+          <p:cNvPr id="32" name="TextBox 31"/>
+          <p:cNvSpPr txBox="1"/>
+          <p:nvPr/>
+        </p:nvSpPr>
+        <p:spPr>
+          <a:xfrm>
+            <a:off x="457200" y="6355080"/>
+            <a:ext cx="7680960" cy="201168"/>
+          </a:xfrm>
+          <a:prstGeom prst="rect">
+            <a:avLst/>
+          </a:prstGeom>
+          <a:noFill/>
+        </p:spPr>
+        <p:txBody>
+          <a:bodyPr wrap="square" lIns="0" rIns="0" tIns="0" bIns="0" anchor="ctr">
+            <a:spAutoFit/>
+          </a:bodyPr>
+          <a:lstStyle/>
+          <a:p>
+            <a:pPr algn="l"/>
+            <a:r>
+              <a:rPr sz="1100" b="1" i="0">
                 <a:solidFill>
                   <a:srgbClr val="3BD67A"/>
                 </a:solidFill>
                 <a:latin typeface="Menlo"/>
               </a:rPr>
-              <a:t>github.com/CyberRant-lab/Defcon</a:t>
+              <a:t>  github.com/CyberRant-lab/Defcon</a:t>
             </a:r>
           </a:p>
         </p:txBody>

</xml_diff>